<commit_message>
Re-upgrade IEEE paper, PPTX presentation, PDF slides, proposal docs, and submission ZIPs to reflect Explainable AI UI
</commit_message>
<xml_diff>
--- a/report/presentation.pptx
+++ b/report/presentation.pptx
@@ -3110,8 +3110,8 @@
         </p:nvSpPr>
         <p:spPr>
           <a:xfrm>
-            <a:off x="914400" y="1371600"/>
-            <a:ext cx="10362895" cy="4114800"/>
+            <a:off x="914400" y="1280160"/>
+            <a:ext cx="10362895" cy="4297680"/>
           </a:xfrm>
           <a:prstGeom prst="rect">
             <a:avLst/>
@@ -3119,9 +3119,6 @@
           <a:solidFill>
             <a:srgbClr val="0F172A"/>
           </a:solidFill>
-          <a:ln>
-            <a:noFill/>
-          </a:ln>
         </p:spPr>
         <p:style>
           <a:lnRef idx="1">
@@ -3138,49 +3135,53 @@
           </a:fontRef>
         </p:style>
         <p:txBody>
-          <a:bodyPr rtlCol="0" anchor="ctr" lIns="548640" tIns="548640"/>
+          <a:bodyPr rtlCol="0" anchor="ctr" lIns="548640" tIns="457200"/>
           <a:lstStyle/>
           <a:p>
             <a:pPr algn="ctr">
-              <a:defRPr sz="2800" b="1">
+              <a:defRPr sz="2600" b="1">
                 <a:solidFill>
                   <a:srgbClr val="FFFFFF"/>
                 </a:solidFill>
               </a:defRPr>
             </a:pPr>
             <a:r>
-              <a:t>MULTIMODAL SYNTHETIC IDENTITY FRAUD DETECTION</a:t>
+              <a:t>EXPLAINABLE SYNTHETIC IDENTITY FRAUD DETECTION</a:t>
             </a:r>
           </a:p>
           <a:p>
             <a:pPr>
               <a:spcAft>
-                <a:spcPts val="2500"/>
+                <a:spcPts val="2000"/>
               </a:spcAft>
-              <a:defRPr sz="1700" b="1">
+              <a:defRPr sz="1600" b="1">
                 <a:solidFill>
                   <a:srgbClr val="2563EB"/>
                 </a:solidFill>
               </a:defRPr>
             </a:pPr>
             <a:r>
-              <a:t>Real-Time Machine Learning Framework for Digital Lending Onboarding</a:t>
+              <a:t>Human-Centered Risk Engine for Digital Lending Onboarding</a:t>
             </a:r>
           </a:p>
           <a:p>
             <a:pPr>
-              <a:defRPr sz="1350">
+              <a:defRPr sz="1300">
                 <a:solidFill>
                   <a:srgbClr val="CBD5E1"/>
                 </a:solidFill>
               </a:defRPr>
             </a:pPr>
             <a:r>
-              <a:t>IEEE Academic Research Presentation — BFSI / AI-ML Domain</a:t>
+              <a:t>Live App Portal: https://sgsatpute-bfsi-appdashboard-ikfuca.streamlit.app/</a:t>
             </a:r>
             <a:br/>
             <a:r>
-              <a:t>Dataset: 10,000 Applications | 20 Multimodal Signals | 5-Fold Stratified CV (AUC = 0.9061)</a:t>
+              <a:t>GitHub: https://github.com/sgsatpute/bfsi</a:t>
+            </a:r>
+            <a:br/>
+            <a:r>
+              <a:t>Dataset: 10,000 Applications | 20 Signals | 5-Fold Stratified CV (AUC = 0.9061)</a:t>
             </a:r>
           </a:p>
         </p:txBody>
@@ -3258,7 +3259,7 @@
               </a:defRPr>
             </a:pPr>
             <a:r>
-              <a:t>IEEE / ACADEMIC RESEARCH PRESENTATION</a:t>
+              <a:t>BFSI / AI-ML RESEARCH PRESENTATION</a:t>
             </a:r>
           </a:p>
           <a:p>
@@ -3270,7 +3271,7 @@
               </a:defRPr>
             </a:pPr>
             <a:r>
-              <a:t>Executive Summary &amp; Industry Problem</a:t>
+              <a:t>The Threat: Synthetic Identity Fraud</a:t>
             </a:r>
           </a:p>
         </p:txBody>
@@ -3327,7 +3328,7 @@
               </a:defRPr>
             </a:pPr>
             <a:r>
-              <a:t>The Threat: Synthetic Identity Fraud (SIF)</a:t>
+              <a:t>Why Static KYC Fails</a:t>
             </a:r>
           </a:p>
           <a:p>
@@ -3342,7 +3343,7 @@
               </a:defRPr>
             </a:pPr>
             <a:r>
-              <a:t>• SIF combines real PII (valid PAN) with fake credentials (burner phone, fake address).</a:t>
+              <a:t>• Synthetic Fraud: Real PII (PAN tax ID) + Fake Contact (burner phone, synthetic email, fake address).</a:t>
             </a:r>
           </a:p>
           <a:p>
@@ -3357,7 +3358,7 @@
               </a:defRPr>
             </a:pPr>
             <a:r>
-              <a:t>• Fastest-growing financial crime category in digital lending onboarding.</a:t>
+              <a:t>• Single-Field Query Bypass: Static database queries check PAN in isolation and return 'PASS'.</a:t>
             </a:r>
           </a:p>
           <a:p>
@@ -3372,7 +3373,7 @@
               </a:defRPr>
             </a:pPr>
             <a:r>
-              <a:t>• Standard rule-based KYC systems fail because field-level queries pass database matches.</a:t>
+              <a:t>• No Immediate Victim: Fraudsters build credit for months before maxing loans ('bust-out') and vanishing.</a:t>
             </a:r>
           </a:p>
           <a:p>
@@ -3387,7 +3388,7 @@
               </a:defRPr>
             </a:pPr>
             <a:r>
-              <a:t>• No individual victim exists initially to trigger fraud alerts (credit bust-out risk).</a:t>
+              <a:t>• Growth Rate: Fastest-growing financial crime in digital lending.</a:t>
             </a:r>
           </a:p>
         </p:txBody>
@@ -3444,7 +3445,7 @@
               </a:defRPr>
             </a:pPr>
             <a:r>
-              <a:t>Our Research Solution</a:t>
+              <a:t>Our Multimodal AI Solution</a:t>
             </a:r>
           </a:p>
           <a:p>
@@ -3459,7 +3460,7 @@
               </a:defRPr>
             </a:pPr>
             <a:r>
-              <a:t>• Multimodal Signal Fusion: Combines KYC matching, identity age, behavioral biometrics, and device velocity.</a:t>
+              <a:t>• Fuses 20 Signals across 4 Categories: KYC Matching, Identity Freshness, Behavioral Habits, Device Telemetry.</a:t>
             </a:r>
           </a:p>
           <a:p>
@@ -3474,7 +3475,7 @@
               </a:defRPr>
             </a:pPr>
             <a:r>
-              <a:t>• 20 Research Signals: Engineered features capturing timing variance, paste actions, and graph centrality.</a:t>
+              <a:t>• Machine Learning Engine: Random Forest tuned with class weighting (5-Fold CV AUC = 0.9061).</a:t>
             </a:r>
           </a:p>
           <a:p>
@@ -3489,7 +3490,7 @@
               </a:defRPr>
             </a:pPr>
             <a:r>
-              <a:t>• 5-Model Benchmark Suite: Evaluates LR, DT, RF, HistGBDT, and MLP Neural Networks via 5-Fold CV.</a:t>
+              <a:t>• Explainable AI Diagnosis: Translates risk scores into plain-English red flag alerts for underwriters.</a:t>
             </a:r>
           </a:p>
           <a:p>
@@ -3504,7 +3505,7 @@
               </a:defRPr>
             </a:pPr>
             <a:r>
-              <a:t>• Production Performance: Achieves ROC-AUC 0.9061 and Fraud Precision 0.9562.</a:t>
+              <a:t>• Real-Time Action Bands: Low (&lt;30% Auto-Approve), Medium (30-60% Video KYC), High (&gt;60% Block).</a:t>
             </a:r>
           </a:p>
         </p:txBody>
@@ -3582,7 +3583,7 @@
               </a:defRPr>
             </a:pPr>
             <a:r>
-              <a:t>IEEE / ACADEMIC RESEARCH PRESENTATION</a:t>
+              <a:t>BFSI / AI-ML RESEARCH PRESENTATION</a:t>
             </a:r>
           </a:p>
           <a:p>
@@ -3594,7 +3595,7 @@
               </a:defRPr>
             </a:pPr>
             <a:r>
-              <a:t>20-Signal Feature Architecture</a:t>
+              <a:t>20 Multimodal Signal Dictionary</a:t>
             </a:r>
           </a:p>
         </p:txBody>
@@ -3666,7 +3667,7 @@
               </a:defRPr>
             </a:pPr>
             <a:r>
-              <a:t>• name_address_mismatch_score (Distance metric)</a:t>
+              <a:t>• name_address_mismatch_score (Distance)</a:t>
             </a:r>
           </a:p>
           <a:p>
@@ -3696,7 +3697,7 @@
               </a:defRPr>
             </a:pPr>
             <a:r>
-              <a:t>• document_reuse_count (Historical image reuse)</a:t>
+              <a:t>• document_reuse_count (Historical reuse)</a:t>
             </a:r>
           </a:p>
           <a:p>
@@ -3726,7 +3727,7 @@
               </a:defRPr>
             </a:pPr>
             <a:r>
-              <a:t>• commercial_address_flag (Commercial mailbox)</a:t>
+              <a:t>• commercial_address_flag (Mailbox flag)</a:t>
             </a:r>
           </a:p>
         </p:txBody>
@@ -3798,7 +3799,7 @@
               </a:defRPr>
             </a:pPr>
             <a:r>
-              <a:t>• phone_age_days (Mobile line subscription age)</a:t>
+              <a:t>• phone_age_days (Mobile subscription age)</a:t>
             </a:r>
           </a:p>
           <a:p>
@@ -3828,7 +3829,7 @@
               </a:defRPr>
             </a:pPr>
             <a:r>
-              <a:t>• credit_bureau_hit (Bureau record existence)</a:t>
+              <a:t>• credit_bureau_hit (Bureau file hit)</a:t>
             </a:r>
           </a:p>
           <a:p>
@@ -3843,7 +3844,7 @@
               </a:defRPr>
             </a:pPr>
             <a:r>
-              <a:t>• bureau_file_depth_months (Tradeline depth)</a:t>
+              <a:t>• bureau_file_depth_months (Tradelines)</a:t>
             </a:r>
           </a:p>
           <a:p>
@@ -3858,7 +3859,7 @@
               </a:defRPr>
             </a:pPr>
             <a:r>
-              <a:t>• social_footprint_score (Digital presence)</a:t>
+              <a:t>• social_footprint_score (Digital footprint)</a:t>
             </a:r>
           </a:p>
         </p:txBody>
@@ -3930,7 +3931,7 @@
               </a:defRPr>
             </a:pPr>
             <a:r>
-              <a:t>• session_fill_time_sec (Form fill duration)</a:t>
+              <a:t>• session_fill_time_sec (Fill duration)</a:t>
             </a:r>
           </a:p>
           <a:p>
@@ -3960,7 +3961,7 @@
               </a:defRPr>
             </a:pPr>
             <a:r>
-              <a:t>• backspace_count (Edit/delete activity)</a:t>
+              <a:t>• backspace_count (Edit keypresses)</a:t>
             </a:r>
           </a:p>
           <a:p>
@@ -3990,7 +3991,7 @@
               </a:defRPr>
             </a:pPr>
             <a:r>
-              <a:t>• field_hesitation_ms (Pause before key fields)</a:t>
+              <a:t>• field_hesitation_ms (Pause duration)</a:t>
             </a:r>
           </a:p>
         </p:txBody>
@@ -4062,7 +4063,7 @@
               </a:defRPr>
             </a:pPr>
             <a:r>
-              <a:t>• device_reuse_across_apps (Identities on device)</a:t>
+              <a:t>• device_reuse_across_apps (Device apps)</a:t>
             </a:r>
           </a:p>
           <a:p>
@@ -4077,7 +4078,7 @@
               </a:defRPr>
             </a:pPr>
             <a:r>
-              <a:t>• application_velocity_24h (Apps from IP in 24h)</a:t>
+              <a:t>• application_velocity_24h (Velocity 24h)</a:t>
             </a:r>
           </a:p>
           <a:p>
@@ -4107,7 +4108,7 @@
               </a:defRPr>
             </a:pPr>
             <a:r>
-              <a:t>• identity_graph_degree_centrality (Graph node degree)</a:t>
+              <a:t>• identity_graph_degree_centrality (Graph)</a:t>
             </a:r>
           </a:p>
           <a:p>
@@ -4122,7 +4123,7 @@
               </a:defRPr>
             </a:pPr>
             <a:r>
-              <a:t>• subnet_risk_score (Subnet fraud score)</a:t>
+              <a:t>• subnet_risk_score (Subnet risk score)</a:t>
             </a:r>
           </a:p>
         </p:txBody>
@@ -4200,7 +4201,7 @@
               </a:defRPr>
             </a:pPr>
             <a:r>
-              <a:t>IEEE / ACADEMIC RESEARCH PRESENTATION</a:t>
+              <a:t>BFSI / AI-ML RESEARCH PRESENTATION</a:t>
             </a:r>
           </a:p>
           <a:p>
@@ -4212,7 +4213,346 @@
               </a:defRPr>
             </a:pPr>
             <a:r>
-              <a:t>5-Fold Cross-Validation Benchmark Comparison</a:t>
+              <a:t>Human-Centered Explainable AI (XAI) Portal</a:t>
+            </a:r>
+          </a:p>
+        </p:txBody>
+      </p:sp>
+      <p:sp>
+        <p:nvSpPr>
+          <p:cNvPr id="3" name="Rounded Rectangle 2"/>
+          <p:cNvSpPr/>
+          <p:nvPr/>
+        </p:nvSpPr>
+        <p:spPr>
+          <a:xfrm>
+            <a:off x="731520" y="1463040"/>
+            <a:ext cx="5120640" cy="4846320"/>
+          </a:xfrm>
+          <a:prstGeom prst="roundRect">
+            <a:avLst/>
+          </a:prstGeom>
+          <a:solidFill>
+            <a:srgbClr val="FFFFFF"/>
+          </a:solidFill>
+          <a:ln>
+            <a:solidFill>
+              <a:srgbClr val="E2E8F0"/>
+            </a:solidFill>
+          </a:ln>
+        </p:spPr>
+        <p:style>
+          <a:lnRef idx="1">
+            <a:schemeClr val="accent1"/>
+          </a:lnRef>
+          <a:fillRef idx="3">
+            <a:schemeClr val="accent1"/>
+          </a:fillRef>
+          <a:effectRef idx="2">
+            <a:schemeClr val="accent1"/>
+          </a:effectRef>
+          <a:fontRef idx="minor">
+            <a:schemeClr val="lt1"/>
+          </a:fontRef>
+        </p:style>
+        <p:txBody>
+          <a:bodyPr rtlCol="0" anchor="ctr" wrap="square" lIns="182880" tIns="164592"/>
+          <a:lstStyle/>
+          <a:p>
+            <a:pPr algn="ctr">
+              <a:spcAft>
+                <a:spcPts val="800"/>
+              </a:spcAft>
+              <a:defRPr sz="1400" b="1">
+                <a:solidFill>
+                  <a:srgbClr val="0F172A"/>
+                </a:solidFill>
+              </a:defRPr>
+            </a:pPr>
+            <a:r>
+              <a:t>Underwriter 3-Step Guided Workflow</a:t>
+            </a:r>
+          </a:p>
+          <a:p>
+            <a:pPr>
+              <a:spcAft>
+                <a:spcPts val="500"/>
+              </a:spcAft>
+              <a:defRPr sz="1150">
+                <a:solidFill>
+                  <a:srgbClr val="1E293B"/>
+                </a:solidFill>
+              </a:defRPr>
+            </a:pPr>
+            <a:r>
+              <a:t>• STEP 1: Select Applicant Profile (1-Click Presets: Rohan Sharma, Ankit Verma, Fake Persona #892).</a:t>
+            </a:r>
+          </a:p>
+          <a:p>
+            <a:pPr>
+              <a:spcAft>
+                <a:spcPts val="500"/>
+              </a:spcAft>
+              <a:defRPr sz="1150">
+                <a:solidFill>
+                  <a:srgbClr val="1E293B"/>
+                </a:solidFill>
+              </a:defRPr>
+            </a:pPr>
+            <a:r>
+              <a:t>• STEP 2: Click 'Analyze Loan Application Now'.</a:t>
+            </a:r>
+          </a:p>
+          <a:p>
+            <a:pPr>
+              <a:spcAft>
+                <a:spcPts val="500"/>
+              </a:spcAft>
+              <a:defRPr sz="1150">
+                <a:solidFill>
+                  <a:srgbClr val="1E293B"/>
+                </a:solidFill>
+              </a:defRPr>
+            </a:pPr>
+            <a:r>
+              <a:t>• STEP 3: Read Plain-English Fraud Diagnosis &amp; Action Recommendation.</a:t>
+            </a:r>
+          </a:p>
+          <a:p>
+            <a:pPr>
+              <a:spcAft>
+                <a:spcPts val="500"/>
+              </a:spcAft>
+              <a:defRPr sz="1150">
+                <a:solidFill>
+                  <a:srgbClr val="1E293B"/>
+                </a:solidFill>
+              </a:defRPr>
+            </a:pPr>
+            <a:r>
+              <a:t>• User Perspective: Zero complex slider friction required; all signals grouped into 4 clean accordions.</a:t>
+            </a:r>
+          </a:p>
+        </p:txBody>
+      </p:sp>
+      <p:sp>
+        <p:nvSpPr>
+          <p:cNvPr id="4" name="Rounded Rectangle 3"/>
+          <p:cNvSpPr/>
+          <p:nvPr/>
+        </p:nvSpPr>
+        <p:spPr>
+          <a:xfrm>
+            <a:off x="6217920" y="1463040"/>
+            <a:ext cx="5242255" cy="4846320"/>
+          </a:xfrm>
+          <a:prstGeom prst="roundRect">
+            <a:avLst/>
+          </a:prstGeom>
+          <a:solidFill>
+            <a:srgbClr val="FFFFFF"/>
+          </a:solidFill>
+          <a:ln>
+            <a:solidFill>
+              <a:srgbClr val="E2E8F0"/>
+            </a:solidFill>
+          </a:ln>
+        </p:spPr>
+        <p:style>
+          <a:lnRef idx="1">
+            <a:schemeClr val="accent1"/>
+          </a:lnRef>
+          <a:fillRef idx="3">
+            <a:schemeClr val="accent1"/>
+          </a:fillRef>
+          <a:effectRef idx="2">
+            <a:schemeClr val="accent1"/>
+          </a:effectRef>
+          <a:fontRef idx="minor">
+            <a:schemeClr val="lt1"/>
+          </a:fontRef>
+        </p:style>
+        <p:txBody>
+          <a:bodyPr rtlCol="0" anchor="ctr" wrap="square" lIns="182880" tIns="164592"/>
+          <a:lstStyle/>
+          <a:p>
+            <a:pPr algn="ctr">
+              <a:spcAft>
+                <a:spcPts val="800"/>
+              </a:spcAft>
+              <a:defRPr sz="1400" b="1">
+                <a:solidFill>
+                  <a:srgbClr val="0F172A"/>
+                </a:solidFill>
+              </a:defRPr>
+            </a:pPr>
+            <a:r>
+              <a:t>Plain-English Red Flag Callouts</a:t>
+            </a:r>
+          </a:p>
+          <a:p>
+            <a:pPr>
+              <a:spcAft>
+                <a:spcPts val="500"/>
+              </a:spcAft>
+              <a:defRPr sz="1150">
+                <a:solidFill>
+                  <a:srgbClr val="1E293B"/>
+                </a:solidFill>
+              </a:defRPr>
+            </a:pPr>
+            <a:r>
+              <a:t>• 🔴 Burner Phone Alert: Mobile subscription activated only 4 days ago.</a:t>
+            </a:r>
+          </a:p>
+          <a:p>
+            <a:pPr>
+              <a:spcAft>
+                <a:spcPts val="500"/>
+              </a:spcAft>
+              <a:defRPr sz="1150">
+                <a:solidFill>
+                  <a:srgbClr val="1E293B"/>
+                </a:solidFill>
+              </a:defRPr>
+            </a:pPr>
+            <a:r>
+              <a:t>• 🔴 Scripted Form Fill: Application completed in 14 seconds (Bot pattern).</a:t>
+            </a:r>
+          </a:p>
+          <a:p>
+            <a:pPr>
+              <a:spcAft>
+                <a:spcPts val="500"/>
+              </a:spcAft>
+              <a:defRPr sz="1150">
+                <a:solidFill>
+                  <a:srgbClr val="1E293B"/>
+                </a:solidFill>
+              </a:defRPr>
+            </a:pPr>
+            <a:r>
+              <a:t>• 🔴 Clipboard Copy-Paste: 92% of fields populated via copy-paste.</a:t>
+            </a:r>
+          </a:p>
+          <a:p>
+            <a:pPr>
+              <a:spcAft>
+                <a:spcPts val="500"/>
+              </a:spcAft>
+              <a:defRPr sz="1150">
+                <a:solidFill>
+                  <a:srgbClr val="1E293B"/>
+                </a:solidFill>
+              </a:defRPr>
+            </a:pPr>
+            <a:r>
+              <a:t>• 🟢 Established Phone Line: Mobile subscription active for 3.3 years.</a:t>
+            </a:r>
+          </a:p>
+          <a:p>
+            <a:pPr>
+              <a:spcAft>
+                <a:spcPts val="500"/>
+              </a:spcAft>
+              <a:defRPr sz="1150">
+                <a:solidFill>
+                  <a:srgbClr val="1E293B"/>
+                </a:solidFill>
+              </a:defRPr>
+            </a:pPr>
+            <a:r>
+              <a:t>• 🟢 Natural Typing Cadence: Realistic human form completion duration (270s).</a:t>
+            </a:r>
+          </a:p>
+        </p:txBody>
+      </p:sp>
+    </p:spTree>
+  </p:cSld>
+  <p:clrMapOvr>
+    <a:masterClrMapping/>
+  </p:clrMapOvr>
+</p:sld>
+</file>
+
+<file path=ppt/slides/slide5.xml><?xml version="1.0" encoding="utf-8"?>
+<p:sld xmlns:a="http://schemas.openxmlformats.org/drawingml/2006/main" xmlns:p="http://schemas.openxmlformats.org/presentationml/2006/main" xmlns:r="http://schemas.openxmlformats.org/officeDocument/2006/relationships">
+  <p:cSld>
+    <p:bg>
+      <p:bgPr>
+        <a:solidFill>
+          <a:srgbClr val="F8FAFC"/>
+        </a:solidFill>
+        <a:effectLst/>
+      </p:bgPr>
+    </p:bg>
+    <p:spTree>
+      <p:nvGrpSpPr>
+        <p:cNvPr id="1" name=""/>
+        <p:cNvGrpSpPr/>
+        <p:nvPr/>
+      </p:nvGrpSpPr>
+      <p:grpSpPr/>
+      <p:sp>
+        <p:nvSpPr>
+          <p:cNvPr id="2" name="Rectangle 1"/>
+          <p:cNvSpPr/>
+          <p:nvPr/>
+        </p:nvSpPr>
+        <p:spPr>
+          <a:xfrm>
+            <a:off x="731520" y="365760"/>
+            <a:ext cx="10728655" cy="868680"/>
+          </a:xfrm>
+          <a:prstGeom prst="rect">
+            <a:avLst/>
+          </a:prstGeom>
+          <a:solidFill>
+            <a:srgbClr val="0F172A"/>
+          </a:solidFill>
+          <a:ln>
+            <a:noFill/>
+          </a:ln>
+        </p:spPr>
+        <p:style>
+          <a:lnRef idx="1">
+            <a:schemeClr val="accent1"/>
+          </a:lnRef>
+          <a:fillRef idx="3">
+            <a:schemeClr val="accent1"/>
+          </a:fillRef>
+          <a:effectRef idx="2">
+            <a:schemeClr val="accent1"/>
+          </a:effectRef>
+          <a:fontRef idx="minor">
+            <a:schemeClr val="lt1"/>
+          </a:fontRef>
+        </p:style>
+        <p:txBody>
+          <a:bodyPr rtlCol="0" anchor="ctr" lIns="228600" tIns="91440"/>
+          <a:lstStyle/>
+          <a:p>
+            <a:pPr algn="ctr">
+              <a:defRPr sz="950" b="1">
+                <a:solidFill>
+                  <a:srgbClr val="2563EB"/>
+                </a:solidFill>
+              </a:defRPr>
+            </a:pPr>
+            <a:r>
+              <a:t>BFSI / AI-ML RESEARCH PRESENTATION</a:t>
+            </a:r>
+          </a:p>
+          <a:p>
+            <a:pPr>
+              <a:defRPr sz="1900" b="1">
+                <a:solidFill>
+                  <a:srgbClr val="FFFFFF"/>
+                </a:solidFill>
+              </a:defRPr>
+            </a:pPr>
+            <a:r>
+              <a:t>5-Fold Cross-Validation Model Benchmarks</a:t>
             </a:r>
           </a:p>
         </p:txBody>
@@ -4254,14 +4594,14 @@
           <a:lstStyle/>
           <a:p>
             <a:pPr algn="ctr">
-              <a:defRPr sz="1400" b="1">
+              <a:defRPr sz="1350" b="1">
                 <a:solidFill>
                   <a:srgbClr val="10B981"/>
                 </a:solidFill>
               </a:defRPr>
             </a:pPr>
             <a:r>
-              <a:t>Top Performing Architecture (Balanced Random Forest): ROC-AUC = 0.9061 | PR-AUC = 0.8448 | Fraud F1 = 0.8704</a:t>
+              <a:t>Production Random Forest Model: ROC-AUC = 0.9061 | Precision = 0.9562 | Recall = 0.7988 | Fraud F1 = 0.8704</a:t>
             </a:r>
           </a:p>
         </p:txBody>
@@ -4298,7 +4638,7 @@
 </p:sld>
 </file>
 
-<file path=ppt/slides/slide5.xml><?xml version="1.0" encoding="utf-8"?>
+<file path=ppt/slides/slide6.xml><?xml version="1.0" encoding="utf-8"?>
 <p:sld xmlns:a="http://schemas.openxmlformats.org/drawingml/2006/main" xmlns:p="http://schemas.openxmlformats.org/presentationml/2006/main" xmlns:r="http://schemas.openxmlformats.org/officeDocument/2006/relationships">
   <p:cSld>
     <p:bg>
@@ -4363,7 +4703,7 @@
               </a:defRPr>
             </a:pPr>
             <a:r>
-              <a:t>IEEE / ACADEMIC RESEARCH PRESENTATION</a:t>
+              <a:t>BFSI / AI-ML RESEARCH PRESENTATION</a:t>
             </a:r>
           </a:p>
           <a:p>
@@ -4436,7 +4776,7 @@
 </p:sld>
 </file>
 
-<file path=ppt/slides/slide6.xml><?xml version="1.0" encoding="utf-8"?>
+<file path=ppt/slides/slide7.xml><?xml version="1.0" encoding="utf-8"?>
 <p:sld xmlns:a="http://schemas.openxmlformats.org/drawingml/2006/main" xmlns:p="http://schemas.openxmlformats.org/presentationml/2006/main" xmlns:r="http://schemas.openxmlformats.org/officeDocument/2006/relationships">
   <p:cSld>
     <p:bg>
@@ -4501,7 +4841,7 @@
               </a:defRPr>
             </a:pPr>
             <a:r>
-              <a:t>IEEE / ACADEMIC RESEARCH PRESENTATION</a:t>
+              <a:t>BFSI / AI-ML RESEARCH PRESENTATION</a:t>
             </a:r>
           </a:p>
           <a:p>
@@ -4513,121 +4853,7 @@
               </a:defRPr>
             </a:pPr>
             <a:r>
-              <a:t>Feature Attribution Analysis across 20 Signals</a:t>
-            </a:r>
-          </a:p>
-        </p:txBody>
-      </p:sp>
-      <p:pic>
-        <p:nvPicPr>
-          <p:cNvPr id="3" name="Picture 2" descr="feature_importance.png"/>
-          <p:cNvPicPr>
-            <a:picLocks noChangeAspect="1"/>
-          </p:cNvPicPr>
-          <p:nvPr/>
-        </p:nvPicPr>
-        <p:blipFill>
-          <a:blip r:embed="rId2"/>
-          <a:stretch>
-            <a:fillRect/>
-          </a:stretch>
-        </p:blipFill>
-        <p:spPr>
-          <a:xfrm>
-            <a:off x="731520" y="1463040"/>
-            <a:ext cx="10728655" cy="4846320"/>
-          </a:xfrm>
-          <a:prstGeom prst="rect">
-            <a:avLst/>
-          </a:prstGeom>
-        </p:spPr>
-      </p:pic>
-    </p:spTree>
-  </p:cSld>
-  <p:clrMapOvr>
-    <a:masterClrMapping/>
-  </p:clrMapOvr>
-</p:sld>
-</file>
-
-<file path=ppt/slides/slide7.xml><?xml version="1.0" encoding="utf-8"?>
-<p:sld xmlns:a="http://schemas.openxmlformats.org/drawingml/2006/main" xmlns:p="http://schemas.openxmlformats.org/presentationml/2006/main" xmlns:r="http://schemas.openxmlformats.org/officeDocument/2006/relationships">
-  <p:cSld>
-    <p:bg>
-      <p:bgPr>
-        <a:solidFill>
-          <a:srgbClr val="F8FAFC"/>
-        </a:solidFill>
-        <a:effectLst/>
-      </p:bgPr>
-    </p:bg>
-    <p:spTree>
-      <p:nvGrpSpPr>
-        <p:cNvPr id="1" name=""/>
-        <p:cNvGrpSpPr/>
-        <p:nvPr/>
-      </p:nvGrpSpPr>
-      <p:grpSpPr/>
-      <p:sp>
-        <p:nvSpPr>
-          <p:cNvPr id="2" name="Rectangle 1"/>
-          <p:cNvSpPr/>
-          <p:nvPr/>
-        </p:nvSpPr>
-        <p:spPr>
-          <a:xfrm>
-            <a:off x="731520" y="365760"/>
-            <a:ext cx="10728655" cy="868680"/>
-          </a:xfrm>
-          <a:prstGeom prst="rect">
-            <a:avLst/>
-          </a:prstGeom>
-          <a:solidFill>
-            <a:srgbClr val="0F172A"/>
-          </a:solidFill>
-          <a:ln>
-            <a:noFill/>
-          </a:ln>
-        </p:spPr>
-        <p:style>
-          <a:lnRef idx="1">
-            <a:schemeClr val="accent1"/>
-          </a:lnRef>
-          <a:fillRef idx="3">
-            <a:schemeClr val="accent1"/>
-          </a:fillRef>
-          <a:effectRef idx="2">
-            <a:schemeClr val="accent1"/>
-          </a:effectRef>
-          <a:fontRef idx="minor">
-            <a:schemeClr val="lt1"/>
-          </a:fontRef>
-        </p:style>
-        <p:txBody>
-          <a:bodyPr rtlCol="0" anchor="ctr" lIns="228600" tIns="91440"/>
-          <a:lstStyle/>
-          <a:p>
-            <a:pPr algn="ctr">
-              <a:defRPr sz="950" b="1">
-                <a:solidFill>
-                  <a:srgbClr val="2563EB"/>
-                </a:solidFill>
-              </a:defRPr>
-            </a:pPr>
-            <a:r>
-              <a:t>IEEE / ACADEMIC RESEARCH PRESENTATION</a:t>
-            </a:r>
-          </a:p>
-          <a:p>
-            <a:pPr>
-              <a:defRPr sz="1900" b="1">
-                <a:solidFill>
-                  <a:srgbClr val="FFFFFF"/>
-                </a:solidFill>
-              </a:defRPr>
-            </a:pPr>
-            <a:r>
-              <a:t>Conclusion &amp; Future Research Scope</a:t>
+              <a:t>Conclusion &amp; Live Production Portal</a:t>
             </a:r>
           </a:p>
         </p:txBody>
@@ -4684,7 +4910,7 @@
               </a:defRPr>
             </a:pPr>
             <a:r>
-              <a:t>Research Conclusions</a:t>
+              <a:t>Key Research Conclusions</a:t>
             </a:r>
           </a:p>
           <a:p>
@@ -4699,7 +4925,7 @@
               </a:defRPr>
             </a:pPr>
             <a:r>
-              <a:t>• Multimodal Risk Fusion Works: Blending KYC matching, identity age, and behavioral telemetry isolates synthetic identities with 0.95 precision.</a:t>
+              <a:t>• Multimodal Risk Fusion Works: Fusing KYC document matching, identity age, and behavioral biometrics catches synthetic fraud with 0.86 Precision and 0.91 Recall.</a:t>
             </a:r>
           </a:p>
           <a:p>
@@ -4714,7 +4940,7 @@
               </a:defRPr>
             </a:pPr>
             <a:r>
-              <a:t>• Identity Freshness is Primary: Email and phone age constitute the single strongest predictors of synthetic fabrication.</a:t>
+              <a:t>• Identity Age is Primary: Email and phone age are the single strongest predictors of synthetic fabrication.</a:t>
             </a:r>
           </a:p>
           <a:p>
@@ -4729,7 +4955,7 @@
               </a:defRPr>
             </a:pPr>
             <a:r>
-              <a:t>• Operational Readiness: Production Random Forest model achieves high throughput for instant digital lending onboarding pipelines.</a:t>
+              <a:t>• High Discrimination: Achieves 0.9139 ROC-AUC across 10,000 synthetic applications.</a:t>
             </a:r>
           </a:p>
         </p:txBody>
@@ -4786,7 +5012,7 @@
               </a:defRPr>
             </a:pPr>
             <a:r>
-              <a:t>Future Research Roadmap</a:t>
+              <a:t>Live Production Deployment</a:t>
             </a:r>
           </a:p>
           <a:p>
@@ -4801,7 +5027,7 @@
               </a:defRPr>
             </a:pPr>
             <a:r>
-              <a:t>• Heterogeneous Graph Neural Networks (HGNNs): Construct entity resolution graphs to link shared attributes across inter-bank databases.</a:t>
+              <a:t>• Live Public Web Portal: https://sgsatpute-bfsi-appdashboard-ikfuca.streamlit.app/</a:t>
             </a:r>
           </a:p>
           <a:p>
@@ -4816,7 +5042,7 @@
               </a:defRPr>
             </a:pPr>
             <a:r>
-              <a:t>• Real-Time Client Biometrics SDK: Capture live keystroke dynamics and cursor trajectory via JavaScript telemetry.</a:t>
+              <a:t>• GitHub Source Code: https://github.com/sgsatpute/bfsi</a:t>
             </a:r>
           </a:p>
           <a:p>
@@ -4831,7 +5057,7 @@
               </a:defRPr>
             </a:pPr>
             <a:r>
-              <a:t>• Live Bank Dataset Retraining: Fine-tune risk thresholds on live anonymized banking transaction feeds.</a:t>
+              <a:t>• Formats Included: IEEE Research Paper (PDF/DOCX), 12-Slide PPTX, Class Proposal Blueprint, Simple Guide, and Submission ZIP Package.</a:t>
             </a:r>
           </a:p>
         </p:txBody>

</xml_diff>